<commit_message>
feat(ui): apply UI corrections, light theme styling, and guardrails integration
</commit_message>
<xml_diff>
--- a/cortex_ai_Google_Cloud_AI_Builder_Cup_Submission.pptx
+++ b/cortex_ai_Google_Cloud_AI_Builder_Cup_Submission.pptx
@@ -9104,7 +9104,7 @@
               </a:defRPr>
             </a:pPr>
             <a:r>
-              <a:t>3. MODEL ARMOR GUARDRAILS &amp; HUMAN-IN-THE-LOOP</a:t>
+              <a:t>3. SHIELDGEMMA &amp; MODEL ARMOR GUARDRAILS</a:t>
             </a:r>
           </a:p>
         </p:txBody>
@@ -9139,7 +9139,7 @@
               </a:defRPr>
             </a:pPr>
             <a:r>
-              <a:t>• Real-time prompt injection interception (jailbreaks, prompt leaks).</a:t>
+              <a:t>• Google ShieldGemma &amp; Model Armor prompt injection interception (jailbreaks, leaks).</a:t>
             </a:r>
           </a:p>
           <a:p>

</xml_diff>